<commit_message>
Update presentation slides to final version
Revised the conclusion slides.
</commit_message>
<xml_diff>
--- a/Group_22_Presentation.pptx
+++ b/Group_22_Presentation.pptx
@@ -211,7 +211,7 @@
           <a:p>
             <a:fld id="{D9ACFF66-7EB0-9844-92BF-09704711A1FD}" type="datetimeFigureOut">
               <a:rPr lang="en-US" smtClean="0"/>
-              <a:t>3/21/2026</a:t>
+              <a:t>3/23/2026</a:t>
             </a:fld>
             <a:endParaRPr lang="en-US"/>
           </a:p>
@@ -2596,7 +2596,7 @@
           <a:p>
             <a:fld id="{758DFB0F-4570-4E46-88F7-D5DC70EA90D0}" type="datetimeFigureOut">
               <a:rPr lang="en-US" smtClean="0"/>
-              <a:t>3/21/2026</a:t>
+              <a:t>3/23/2026</a:t>
             </a:fld>
             <a:endParaRPr lang="en-US"/>
           </a:p>
@@ -3559,7 +3559,7 @@
           <a:p>
             <a:fld id="{758DFB0F-4570-4E46-88F7-D5DC70EA90D0}" type="datetimeFigureOut">
               <a:rPr lang="en-US" smtClean="0"/>
-              <a:t>3/21/2026</a:t>
+              <a:t>3/23/2026</a:t>
             </a:fld>
             <a:endParaRPr lang="en-US"/>
           </a:p>
@@ -3900,7 +3900,7 @@
           <a:p>
             <a:fld id="{758DFB0F-4570-4E46-88F7-D5DC70EA90D0}" type="datetimeFigureOut">
               <a:rPr lang="en-US" smtClean="0"/>
-              <a:t>3/21/2026</a:t>
+              <a:t>3/23/2026</a:t>
             </a:fld>
             <a:endParaRPr lang="en-US"/>
           </a:p>
@@ -4219,7 +4219,7 @@
           <a:p>
             <a:fld id="{758DFB0F-4570-4E46-88F7-D5DC70EA90D0}" type="datetimeFigureOut">
               <a:rPr lang="en-US" smtClean="0"/>
-              <a:t>3/21/2026</a:t>
+              <a:t>3/23/2026</a:t>
             </a:fld>
             <a:endParaRPr lang="en-US"/>
           </a:p>
@@ -4544,7 +4544,7 @@
           <a:p>
             <a:fld id="{758DFB0F-4570-4E46-88F7-D5DC70EA90D0}" type="datetimeFigureOut">
               <a:rPr lang="en-US" smtClean="0"/>
-              <a:t>3/21/2026</a:t>
+              <a:t>3/23/2026</a:t>
             </a:fld>
             <a:endParaRPr lang="en-US"/>
           </a:p>
@@ -4796,7 +4796,7 @@
           <a:p>
             <a:fld id="{758DFB0F-4570-4E46-88F7-D5DC70EA90D0}" type="datetimeFigureOut">
               <a:rPr lang="en-US" smtClean="0"/>
-              <a:t>3/21/2026</a:t>
+              <a:t>3/23/2026</a:t>
             </a:fld>
             <a:endParaRPr lang="en-US"/>
           </a:p>
@@ -4969,7 +4969,7 @@
           <a:p>
             <a:fld id="{758DFB0F-4570-4E46-88F7-D5DC70EA90D0}" type="datetimeFigureOut">
               <a:rPr lang="en-US" smtClean="0"/>
-              <a:t>3/21/2026</a:t>
+              <a:t>3/23/2026</a:t>
             </a:fld>
             <a:endParaRPr lang="en-US"/>
           </a:p>
@@ -5226,7 +5226,7 @@
           <a:p>
             <a:fld id="{758DFB0F-4570-4E46-88F7-D5DC70EA90D0}" type="datetimeFigureOut">
               <a:rPr lang="en-US" smtClean="0"/>
-              <a:t>3/21/2026</a:t>
+              <a:t>3/23/2026</a:t>
             </a:fld>
             <a:endParaRPr lang="en-US"/>
           </a:p>
@@ -5550,7 +5550,7 @@
           <a:p>
             <a:fld id="{758DFB0F-4570-4E46-88F7-D5DC70EA90D0}" type="datetimeFigureOut">
               <a:rPr lang="en-US" smtClean="0"/>
-              <a:t>3/21/2026</a:t>
+              <a:t>3/23/2026</a:t>
             </a:fld>
             <a:endParaRPr lang="en-US"/>
           </a:p>
@@ -5772,7 +5772,7 @@
           <a:p>
             <a:fld id="{758DFB0F-4570-4E46-88F7-D5DC70EA90D0}" type="datetimeFigureOut">
               <a:rPr lang="en-US" smtClean="0"/>
-              <a:t>3/21/2026</a:t>
+              <a:t>3/23/2026</a:t>
             </a:fld>
             <a:endParaRPr lang="en-US"/>
           </a:p>
@@ -6671,8 +6671,8 @@
         </p:nvSpPr>
         <p:spPr bwMode="auto">
           <a:xfrm>
-            <a:off x="595313" y="2030065"/>
-            <a:ext cx="11311765" cy="3847207"/>
+            <a:off x="595313" y="1533777"/>
+            <a:ext cx="11311765" cy="5078313"/>
           </a:xfrm>
           <a:prstGeom prst="rect">
             <a:avLst/>
@@ -6732,16 +6732,45 @@
               </a:spcAft>
             </a:pPr>
             <a:r>
-              <a:rPr lang="zh-CN" altLang="zh-CN" dirty="0">
+              <a:rPr lang="en-US" altLang="zh-CN" dirty="0">
                 <a:latin typeface="+mn-lt"/>
               </a:rPr>
-              <a:t>Primary </a:t>
+              <a:t>Spam and non-spam emails showed clear differences in financial, promotional, and emphatic text features.</a:t>
             </a:r>
+          </a:p>
+          <a:p>
+            <a:pPr lvl="0" eaLnBrk="0" fontAlgn="base" hangingPunct="0">
+              <a:lnSpc>
+                <a:spcPct val="100000"/>
+              </a:lnSpc>
+              <a:spcBef>
+                <a:spcPct val="0"/>
+              </a:spcBef>
+              <a:spcAft>
+                <a:spcPct val="0"/>
+              </a:spcAft>
+            </a:pPr>
+            <a:endParaRPr lang="en-US" altLang="zh-CN" dirty="0">
+              <a:latin typeface="+mn-lt"/>
+            </a:endParaRPr>
+          </a:p>
+          <a:p>
+            <a:pPr lvl="0" eaLnBrk="0" fontAlgn="base" hangingPunct="0">
+              <a:lnSpc>
+                <a:spcPct val="100000"/>
+              </a:lnSpc>
+              <a:spcBef>
+                <a:spcPct val="0"/>
+              </a:spcBef>
+              <a:spcAft>
+                <a:spcPct val="0"/>
+              </a:spcAft>
+            </a:pPr>
             <a:r>
               <a:rPr lang="en-US" altLang="zh-CN" dirty="0">
                 <a:latin typeface="+mn-lt"/>
               </a:rPr>
-              <a:t>effect variables: </a:t>
+              <a:t>Strongest predictors:</a:t>
             </a:r>
           </a:p>
           <a:p>
@@ -6766,10 +6795,22 @@
               <a:t>dollar</a:t>
             </a:r>
             <a:r>
+              <a:rPr lang="en-US" altLang="zh-CN" dirty="0">
+                <a:latin typeface="+mn-lt"/>
+              </a:rPr>
+              <a:t> </a:t>
+            </a:r>
+            <a:r>
               <a:rPr lang="en-US" altLang="zh-CN" sz="2000" dirty="0">
                 <a:latin typeface="+mn-lt"/>
               </a:rPr>
-              <a:t> (P &lt; 0.001, OR ≈ 3573), </a:t>
+              <a:t>(P &lt; 0.001, OR ≈ 3573),</a:t>
+            </a:r>
+            <a:r>
+              <a:rPr lang="zh-CN" altLang="en-US" sz="2000" dirty="0">
+                <a:latin typeface="+mn-lt"/>
+              </a:rPr>
+              <a:t> </a:t>
             </a:r>
             <a:r>
               <a:rPr lang="en-US" altLang="zh-CN" sz="2000" b="1" dirty="0">
@@ -6803,7 +6844,7 @@
               <a:rPr lang="en-US" altLang="zh-CN" dirty="0">
                 <a:latin typeface="+mn-lt"/>
               </a:rPr>
-              <a:t>Secondary effect variables: </a:t>
+              <a:t>Moderate predictors:</a:t>
             </a:r>
           </a:p>
           <a:p>
@@ -6828,10 +6869,16 @@
               <a:t>n000</a:t>
             </a:r>
             <a:r>
+              <a:rPr lang="en-US" altLang="zh-CN" dirty="0">
+                <a:latin typeface="+mn-lt"/>
+              </a:rPr>
+              <a:t> </a:t>
+            </a:r>
+            <a:r>
               <a:rPr lang="en-US" altLang="zh-CN" sz="2000" dirty="0">
                 <a:latin typeface="+mn-lt"/>
               </a:rPr>
-              <a:t> (P &lt; 0.01, OR ≈ 30.8), </a:t>
+              <a:t>(P &lt; 0.01, OR ≈ 30.8), </a:t>
             </a:r>
             <a:r>
               <a:rPr lang="en-US" altLang="zh-CN" sz="2000" b="1" dirty="0">
@@ -6865,17 +6912,7 @@
               <a:rPr lang="en-US" altLang="zh-CN" dirty="0">
                 <a:latin typeface="+mn-lt"/>
               </a:rPr>
-              <a:t>Weak effect </a:t>
-            </a:r>
-            <a:r>
-              <a:rPr lang="en-US" altLang="zh-CN" dirty="0"/>
-              <a:t>Variables</a:t>
-            </a:r>
-            <a:r>
-              <a:rPr lang="en-US" altLang="zh-CN" dirty="0">
-                <a:latin typeface="+mn-lt"/>
-              </a:rPr>
-              <a:t>: </a:t>
+              <a:t>Weak practical effect:</a:t>
             </a:r>
           </a:p>
           <a:p>
@@ -6912,7 +6949,57 @@
               <a:rPr lang="en-US" altLang="zh-CN" sz="2000" dirty="0">
                 <a:latin typeface="+mn-lt"/>
               </a:rPr>
-              <a:t>(P &lt; 0.01 (**), OR ≈ 1.001)</a:t>
+              <a:t>was statistically significant, but OR ≈ 1.001, so its practical effect was very small.</a:t>
+            </a:r>
+          </a:p>
+          <a:p>
+            <a:pPr lvl="0" eaLnBrk="0" fontAlgn="base" hangingPunct="0">
+              <a:lnSpc>
+                <a:spcPct val="100000"/>
+              </a:lnSpc>
+              <a:spcBef>
+                <a:spcPct val="0"/>
+              </a:spcBef>
+              <a:spcAft>
+                <a:spcPct val="0"/>
+              </a:spcAft>
+            </a:pPr>
+            <a:endParaRPr lang="en-US" altLang="zh-CN" dirty="0">
+              <a:latin typeface="+mn-lt"/>
+            </a:endParaRPr>
+          </a:p>
+          <a:p>
+            <a:pPr lvl="0" eaLnBrk="0" fontAlgn="base" hangingPunct="0">
+              <a:lnSpc>
+                <a:spcPct val="100000"/>
+              </a:lnSpc>
+              <a:spcBef>
+                <a:spcPct val="0"/>
+              </a:spcBef>
+              <a:spcAft>
+                <a:spcPct val="0"/>
+              </a:spcAft>
+            </a:pPr>
+            <a:r>
+              <a:rPr lang="en-US" altLang="zh-CN" sz="2000" dirty="0">
+                <a:solidFill>
+                  <a:srgbClr val="4DBBC6"/>
+                </a:solidFill>
+                <a:latin typeface="+mn-lt"/>
+              </a:rPr>
+              <a:t>make</a:t>
+            </a:r>
+            <a:r>
+              <a:rPr lang="en-US" altLang="zh-CN" dirty="0">
+                <a:latin typeface="+mn-lt"/>
+              </a:rPr>
+              <a:t> </a:t>
+            </a:r>
+            <a:r>
+              <a:rPr lang="en-US" altLang="zh-CN" sz="2000" dirty="0">
+                <a:latin typeface="+mn-lt"/>
+              </a:rPr>
+              <a:t>was removed from the reduced model, which gave a simpler model while keeping the main useful predictors.</a:t>
             </a:r>
           </a:p>
           <a:p>
@@ -6933,102 +7020,6 @@
             <a:endParaRPr lang="en-US" altLang="zh-CN" dirty="0">
               <a:latin typeface="+mn-lt"/>
             </a:endParaRPr>
-          </a:p>
-          <a:p>
-            <a:pPr marL="0" marR="0" lvl="0" indent="0" algn="l" defTabSz="914400" rtl="0" eaLnBrk="0" fontAlgn="base" latinLnBrk="0" hangingPunct="0">
-              <a:lnSpc>
-                <a:spcPct val="100000"/>
-              </a:lnSpc>
-              <a:spcBef>
-                <a:spcPct val="0"/>
-              </a:spcBef>
-              <a:spcAft>
-                <a:spcPct val="0"/>
-              </a:spcAft>
-              <a:buClrTx/>
-              <a:buSzTx/>
-              <a:tabLst/>
-            </a:pPr>
-            <a:r>
-              <a:rPr lang="zh-CN" altLang="zh-CN" sz="2000" dirty="0">
-                <a:latin typeface="+mn-lt"/>
-              </a:rPr>
-              <a:t>Removing non-significant variables (e.g., </a:t>
-            </a:r>
-            <a:r>
-              <a:rPr lang="zh-CN" altLang="zh-CN" sz="2000" dirty="0">
-                <a:solidFill>
-                  <a:srgbClr val="4DBBC6"/>
-                </a:solidFill>
-                <a:latin typeface="+mn-lt"/>
-              </a:rPr>
-              <a:t>make</a:t>
-            </a:r>
-            <a:r>
-              <a:rPr lang="zh-CN" altLang="zh-CN" sz="2000" dirty="0">
-                <a:latin typeface="+mn-lt"/>
-              </a:rPr>
-              <a:t>) achieved a more</a:t>
-            </a:r>
-            <a:r>
-              <a:rPr lang="en-US" altLang="zh-CN" sz="2000" dirty="0">
-                <a:latin typeface="+mn-lt"/>
-              </a:rPr>
-              <a:t> </a:t>
-            </a:r>
-            <a:r>
-              <a:rPr lang="zh-CN" altLang="zh-CN" sz="2000" dirty="0">
-                <a:latin typeface="+mn-lt"/>
-              </a:rPr>
-              <a:t>parsimonious and efficient filter.</a:t>
-            </a:r>
-          </a:p>
-          <a:p>
-            <a:pPr marL="0" marR="0" lvl="0" indent="0" algn="l" defTabSz="914400" rtl="0" eaLnBrk="0" fontAlgn="base" latinLnBrk="0" hangingPunct="0">
-              <a:lnSpc>
-                <a:spcPct val="100000"/>
-              </a:lnSpc>
-              <a:spcBef>
-                <a:spcPct val="0"/>
-              </a:spcBef>
-              <a:spcAft>
-                <a:spcPct val="0"/>
-              </a:spcAft>
-              <a:buClrTx/>
-              <a:buSzTx/>
-              <a:tabLst/>
-            </a:pPr>
-            <a:endParaRPr lang="en-US" altLang="zh-CN" dirty="0">
-              <a:latin typeface="+mn-lt"/>
-            </a:endParaRPr>
-          </a:p>
-          <a:p>
-            <a:pPr marL="0" marR="0" lvl="0" indent="0" algn="l" defTabSz="914400" rtl="0" eaLnBrk="0" fontAlgn="base" latinLnBrk="0" hangingPunct="0">
-              <a:lnSpc>
-                <a:spcPct val="100000"/>
-              </a:lnSpc>
-              <a:spcBef>
-                <a:spcPct val="0"/>
-              </a:spcBef>
-              <a:spcAft>
-                <a:spcPct val="0"/>
-              </a:spcAft>
-              <a:buClrTx/>
-              <a:buSzTx/>
-              <a:tabLst/>
-            </a:pPr>
-            <a:r>
-              <a:rPr lang="zh-CN" altLang="zh-CN" dirty="0">
-                <a:latin typeface="+mn-lt"/>
-              </a:rPr>
-              <a:t>Performance</a:t>
-            </a:r>
-            <a:r>
-              <a:rPr lang="en-US" altLang="zh-CN" dirty="0">
-                <a:latin typeface="+mn-lt"/>
-              </a:rPr>
-              <a:t>:</a:t>
-            </a:r>
           </a:p>
           <a:p>
             <a:pPr marL="0" marR="0" lvl="0" indent="0" algn="l" defTabSz="914400" rtl="0" eaLnBrk="0" fontAlgn="base" latinLnBrk="0" hangingPunct="0">
@@ -7186,8 +7177,8 @@
         </p:nvSpPr>
         <p:spPr bwMode="auto">
           <a:xfrm>
-            <a:off x="1632813" y="2231705"/>
-            <a:ext cx="8926374" cy="2708434"/>
+            <a:off x="1632813" y="1916248"/>
+            <a:ext cx="8926374" cy="3816429"/>
           </a:xfrm>
           <a:prstGeom prst="rect">
             <a:avLst/>
@@ -7276,7 +7267,7 @@
             </a:endParaRPr>
           </a:p>
           <a:p>
-            <a:pPr marL="0" marR="0" lvl="0" indent="0" algn="l" defTabSz="914400" rtl="0" eaLnBrk="0" fontAlgn="base" latinLnBrk="0" hangingPunct="0">
+            <a:pPr lvl="0" eaLnBrk="0" fontAlgn="base" hangingPunct="0">
               <a:lnSpc>
                 <a:spcPct val="100000"/>
               </a:lnSpc>
@@ -7286,69 +7277,31 @@
               <a:spcAft>
                 <a:spcPct val="0"/>
               </a:spcAft>
-              <a:buClrTx/>
-              <a:buSzTx/>
-              <a:buFontTx/>
-              <a:buNone/>
-              <a:tabLst/>
             </a:pPr>
             <a:r>
-              <a:rPr kumimoji="0" lang="zh-CN" altLang="zh-CN" b="0" i="0" u="none" strike="noStrike" cap="none" normalizeH="0" baseline="0" dirty="0">
-                <a:ln>
-                  <a:noFill/>
-                </a:ln>
-                <a:solidFill>
-                  <a:schemeClr val="tx1"/>
-                </a:solidFill>
-                <a:effectLst/>
-                <a:latin typeface="+mn-lt"/>
-              </a:rPr>
-              <a:t>Model serves as a </a:t>
+              <a:rPr lang="en-US" altLang="zh-CN" dirty="0"/>
+              <a:t>The model used only a limited number of text-based predictors. And some predictors</a:t>
             </a:r>
             <a:r>
-              <a:rPr kumimoji="0" lang="zh-CN" altLang="zh-CN" b="1" i="0" u="none" strike="noStrike" cap="none" normalizeH="0" baseline="0" dirty="0">
-                <a:ln>
-                  <a:noFill/>
-                </a:ln>
-                <a:solidFill>
-                  <a:schemeClr val="tx1"/>
-                </a:solidFill>
-                <a:effectLst/>
-                <a:latin typeface="+mn-lt"/>
-              </a:rPr>
-              <a:t>strong baseline</a:t>
+              <a:rPr lang="zh-CN" altLang="en-US" dirty="0"/>
+              <a:t>（</a:t>
             </a:r>
             <a:r>
-              <a:rPr kumimoji="0" lang="zh-CN" altLang="zh-CN" b="0" i="0" u="none" strike="noStrike" cap="none" normalizeH="0" baseline="0" dirty="0">
-                <a:ln>
-                  <a:noFill/>
-                </a:ln>
-                <a:solidFill>
-                  <a:schemeClr val="tx1"/>
-                </a:solidFill>
-                <a:effectLst/>
-                <a:latin typeface="+mn-lt"/>
-              </a:rPr>
-              <a:t>, not a complete solution.</a:t>
+              <a:rPr lang="en-US" altLang="zh-CN" dirty="0"/>
+              <a:t>e.g., </a:t>
             </a:r>
-          </a:p>
-          <a:p>
-            <a:pPr marL="0" marR="0" lvl="0" indent="0" algn="l" defTabSz="914400" rtl="0" eaLnBrk="0" fontAlgn="base" latinLnBrk="0" hangingPunct="0">
-              <a:lnSpc>
-                <a:spcPct val="100000"/>
-              </a:lnSpc>
-              <a:spcBef>
-                <a:spcPct val="0"/>
-              </a:spcBef>
-              <a:spcAft>
-                <a:spcPct val="0"/>
-              </a:spcAft>
-              <a:buClrTx/>
-              <a:buSzTx/>
-              <a:buFontTx/>
-              <a:buNone/>
-              <a:tabLst/>
-            </a:pPr>
+            <a:r>
+              <a:rPr lang="en-US" altLang="zh-CN" dirty="0" err="1"/>
+              <a:t>crl.tot</a:t>
+            </a:r>
+            <a:r>
+              <a:rPr lang="zh-CN" altLang="en-US" dirty="0"/>
+              <a:t>）</a:t>
+            </a:r>
+            <a:r>
+              <a:rPr lang="en-US" altLang="zh-CN" dirty="0"/>
+              <a:t>were statistically significant but had weak practical effects, so The model should be seen as a useful baseline rather than a final solution.</a:t>
+            </a:r>
             <a:br>
               <a:rPr kumimoji="0" lang="zh-CN" altLang="zh-CN" sz="1800" b="0" i="0" u="none" strike="noStrike" cap="none" normalizeH="0" baseline="0" dirty="0">
                 <a:ln>
@@ -7361,6 +7314,29 @@
                 <a:latin typeface="+mn-lt"/>
               </a:rPr>
             </a:br>
+            <a:endParaRPr kumimoji="0" lang="en-US" altLang="zh-CN" sz="1800" b="0" i="0" u="none" strike="noStrike" cap="none" normalizeH="0" baseline="0" dirty="0">
+              <a:ln>
+                <a:noFill/>
+              </a:ln>
+              <a:solidFill>
+                <a:schemeClr val="tx1"/>
+              </a:solidFill>
+              <a:effectLst/>
+              <a:latin typeface="+mn-lt"/>
+            </a:endParaRPr>
+          </a:p>
+          <a:p>
+            <a:pPr lvl="0" eaLnBrk="0" fontAlgn="base" hangingPunct="0">
+              <a:lnSpc>
+                <a:spcPct val="100000"/>
+              </a:lnSpc>
+              <a:spcBef>
+                <a:spcPct val="0"/>
+              </a:spcBef>
+              <a:spcAft>
+                <a:spcPct val="0"/>
+              </a:spcAft>
+            </a:pPr>
             <a:r>
               <a:rPr kumimoji="0" lang="zh-CN" altLang="zh-CN" sz="2800" b="1" i="0" u="none" strike="noStrike" cap="none" normalizeH="0" baseline="0" dirty="0">
                 <a:ln>
@@ -7372,11 +7348,23 @@
                 <a:effectLst/>
                 <a:latin typeface="+mn-lt"/>
               </a:rPr>
-              <a:t>Future Enhancements:</a:t>
+              <a:t>Future </a:t>
             </a:r>
-          </a:p>
-          <a:p>
-            <a:pPr marL="0" marR="0" lvl="0" indent="0" algn="l" defTabSz="914400" rtl="0" eaLnBrk="0" fontAlgn="base" latinLnBrk="0" hangingPunct="0">
+            <a:r>
+              <a:rPr lang="en-US" altLang="zh-CN" sz="2800" b="1" dirty="0">
+                <a:latin typeface="+mn-lt"/>
+              </a:rPr>
+              <a:t>Work</a:t>
+            </a:r>
+            <a:r>
+              <a:rPr lang="zh-CN" altLang="zh-CN" sz="2800" b="1" dirty="0">
+                <a:latin typeface="+mn-lt"/>
+              </a:rPr>
+              <a:t>:</a:t>
+            </a:r>
+          </a:p>
+          <a:p>
+            <a:pPr lvl="0" eaLnBrk="0" fontAlgn="base" hangingPunct="0">
               <a:lnSpc>
                 <a:spcPct val="100000"/>
               </a:lnSpc>
@@ -7386,54 +7374,16 @@
               <a:spcAft>
                 <a:spcPct val="0"/>
               </a:spcAft>
-              <a:buClrTx/>
-              <a:buSzTx/>
-              <a:buFontTx/>
-              <a:buNone/>
-              <a:tabLst/>
             </a:pPr>
             <a:r>
-              <a:rPr kumimoji="0" lang="en-US" altLang="zh-CN" b="0" i="0" u="none" strike="noStrike" cap="none" normalizeH="0" baseline="0" dirty="0">
-                <a:ln>
-                  <a:noFill/>
-                </a:ln>
-                <a:solidFill>
-                  <a:schemeClr val="tx1"/>
-                </a:solidFill>
-                <a:effectLst/>
+              <a:rPr lang="en-US" altLang="zh-CN" dirty="0">
                 <a:latin typeface="+mn-lt"/>
               </a:rPr>
-              <a:t>1. </a:t>
+              <a:t>Use a larger and more diverse dataset.</a:t>
             </a:r>
-            <a:r>
-              <a:rPr kumimoji="0" lang="zh-CN" altLang="zh-CN" b="0" i="0" u="none" strike="noStrike" cap="none" normalizeH="0" baseline="0" dirty="0">
-                <a:ln>
-                  <a:noFill/>
-                </a:ln>
-                <a:solidFill>
-                  <a:schemeClr val="tx1"/>
-                </a:solidFill>
-                <a:effectLst/>
-                <a:latin typeface="+mn-lt"/>
-              </a:rPr>
-              <a:t>Integrate advanced </a:t>
-            </a:r>
-            <a:r>
-              <a:rPr kumimoji="0" lang="zh-CN" altLang="zh-CN" b="1" i="0" u="none" strike="noStrike" cap="none" normalizeH="0" baseline="0" dirty="0">
-                <a:ln>
-                  <a:noFill/>
-                </a:ln>
-                <a:solidFill>
-                  <a:schemeClr val="tx1"/>
-                </a:solidFill>
-                <a:effectLst/>
-                <a:latin typeface="+mn-lt"/>
-              </a:rPr>
-              <a:t>Natural Language Processing (NLP).</a:t>
-            </a:r>
-          </a:p>
-          <a:p>
-            <a:pPr marL="0" marR="0" lvl="0" indent="0" algn="l" defTabSz="914400" rtl="0" eaLnBrk="0" fontAlgn="base" latinLnBrk="0" hangingPunct="0">
+          </a:p>
+          <a:p>
+            <a:pPr lvl="0" eaLnBrk="0" fontAlgn="base" hangingPunct="0">
               <a:lnSpc>
                 <a:spcPct val="100000"/>
               </a:lnSpc>
@@ -7443,67 +7393,16 @@
               <a:spcAft>
                 <a:spcPct val="0"/>
               </a:spcAft>
-              <a:buClrTx/>
-              <a:buSzTx/>
-              <a:buFontTx/>
-              <a:buNone/>
-              <a:tabLst/>
             </a:pPr>
             <a:r>
-              <a:rPr kumimoji="0" lang="en-US" altLang="zh-CN" b="0" i="0" u="none" strike="noStrike" cap="none" normalizeH="0" baseline="0" dirty="0">
-                <a:ln>
-                  <a:noFill/>
-                </a:ln>
-                <a:solidFill>
-                  <a:schemeClr val="tx1"/>
-                </a:solidFill>
-                <a:effectLst/>
+              <a:rPr lang="en-US" altLang="zh-CN" dirty="0">
                 <a:latin typeface="+mn-lt"/>
               </a:rPr>
-              <a:t>2. </a:t>
+              <a:t>Add more text-based features.</a:t>
             </a:r>
-            <a:r>
-              <a:rPr kumimoji="0" lang="zh-CN" altLang="zh-CN" b="0" i="0" u="none" strike="noStrike" cap="none" normalizeH="0" baseline="0" dirty="0">
-                <a:ln>
-                  <a:noFill/>
-                </a:ln>
-                <a:solidFill>
-                  <a:schemeClr val="tx1"/>
-                </a:solidFill>
-                <a:effectLst/>
-                <a:latin typeface="+mn-lt"/>
-              </a:rPr>
-              <a:t>Test non-linear methods (e.g., </a:t>
-            </a:r>
-            <a:r>
-              <a:rPr kumimoji="0" lang="zh-CN" altLang="zh-CN" b="1" i="0" u="none" strike="noStrike" cap="none" normalizeH="0" baseline="0" dirty="0">
-                <a:ln>
-                  <a:noFill/>
-                </a:ln>
-                <a:solidFill>
-                  <a:schemeClr val="tx1"/>
-                </a:solidFill>
-                <a:effectLst/>
-                <a:latin typeface="+mn-lt"/>
-              </a:rPr>
-              <a:t>Random Forest</a:t>
-            </a:r>
-            <a:r>
-              <a:rPr kumimoji="0" lang="zh-CN" altLang="zh-CN" b="0" i="0" u="none" strike="noStrike" cap="none" normalizeH="0" baseline="0" dirty="0">
-                <a:ln>
-                  <a:noFill/>
-                </a:ln>
-                <a:solidFill>
-                  <a:schemeClr val="tx1"/>
-                </a:solidFill>
-                <a:effectLst/>
-                <a:latin typeface="+mn-lt"/>
-              </a:rPr>
-              <a:t>).</a:t>
-            </a:r>
-          </a:p>
-          <a:p>
-            <a:pPr marL="0" marR="0" lvl="0" indent="0" algn="l" defTabSz="914400" rtl="0" eaLnBrk="0" fontAlgn="base" latinLnBrk="0" hangingPunct="0">
+          </a:p>
+          <a:p>
+            <a:pPr lvl="0" eaLnBrk="0" fontAlgn="base" hangingPunct="0">
               <a:lnSpc>
                 <a:spcPct val="100000"/>
               </a:lnSpc>
@@ -7513,38 +7412,23 @@
               <a:spcAft>
                 <a:spcPct val="0"/>
               </a:spcAft>
-              <a:buClrTx/>
-              <a:buSzTx/>
-              <a:buFontTx/>
-              <a:buNone/>
-              <a:tabLst/>
             </a:pPr>
             <a:r>
-              <a:rPr kumimoji="0" lang="en-US" altLang="zh-CN" b="0" i="0" u="none" strike="noStrike" cap="none" normalizeH="0" baseline="0" dirty="0">
-                <a:ln>
-                  <a:noFill/>
-                </a:ln>
-                <a:solidFill>
-                  <a:schemeClr val="tx1"/>
-                </a:solidFill>
-                <a:effectLst/>
+              <a:rPr lang="en-US" altLang="zh-CN" dirty="0">
                 <a:latin typeface="+mn-lt"/>
               </a:rPr>
-              <a:t>3. </a:t>
+              <a:t>Try other classification methods.</a:t>
             </a:r>
-            <a:r>
-              <a:rPr kumimoji="0" lang="zh-CN" altLang="zh-CN" b="0" i="0" u="none" strike="noStrike" cap="none" normalizeH="0" baseline="0" dirty="0">
-                <a:ln>
-                  <a:noFill/>
-                </a:ln>
-                <a:solidFill>
-                  <a:schemeClr val="tx1"/>
-                </a:solidFill>
-                <a:effectLst/>
-                <a:latin typeface="+mn-lt"/>
-              </a:rPr>
-              <a:t>Expand feature set beyond simple frequencies.</a:t>
-            </a:r>
+            <a:endParaRPr kumimoji="0" lang="zh-CN" altLang="zh-CN" b="0" i="0" u="none" strike="noStrike" cap="none" normalizeH="0" baseline="0" dirty="0">
+              <a:ln>
+                <a:noFill/>
+              </a:ln>
+              <a:solidFill>
+                <a:schemeClr val="tx1"/>
+              </a:solidFill>
+              <a:effectLst/>
+              <a:latin typeface="+mn-lt"/>
+            </a:endParaRPr>
           </a:p>
         </p:txBody>
       </p:sp>
@@ -8297,8 +8181,8 @@
           </a:p>
         </p:txBody>
       </p:sp>
-      <mc:AlternateContent xmlns:mc="http://schemas.openxmlformats.org/markup-compatibility/2006">
-        <mc:Choice xmlns:a14="http://schemas.microsoft.com/office/drawing/2010/main" Requires="a14">
+      <mc:AlternateContent xmlns:mc="http://schemas.openxmlformats.org/markup-compatibility/2006" xmlns:a14="http://schemas.microsoft.com/office/drawing/2010/main">
+        <mc:Choice Requires="a14">
           <p:sp>
             <p:nvSpPr>
               <p:cNvPr id="17" name="Text Placeholder 3">
@@ -8866,7 +8750,7 @@
             </p:txBody>
           </p:sp>
         </mc:Choice>
-        <mc:Fallback>
+        <mc:Fallback xmlns="">
           <p:sp>
             <p:nvSpPr>
               <p:cNvPr id="17" name="Text Placeholder 3">

</xml_diff>